<commit_message>
PowerPoint Awali : ajout de la diapositive Sommaire (plan de la présentation)
</commit_message>
<xml_diff>
--- a/soutenance/KOUASSI_YOO.pptx
+++ b/soutenance/KOUASSI_YOO.pptx
@@ -9,6 +9,7 @@
   </p:notesMasterIdLst>
   <p:sldIdLst>
     <p:sldId id="256" r:id="rId2"/>
+    <p:sldId id="279" r:id="rId23"/>
     <p:sldId id="257" r:id="rId3"/>
     <p:sldId id="260" r:id="rId4"/>
     <p:sldId id="277" r:id="rId5"/>
@@ -13078,6 +13079,1530 @@
               <a:t>Merci pour votre attention</a:t>
             </a:r>
             <a:endParaRPr lang="en-US" dirty="0"/>
+          </a:p>
+        </p:txBody>
+      </p:sp>
+    </p:spTree>
+  </p:cSld>
+  <p:clrMapOvr>
+    <a:masterClrMapping/>
+  </p:clrMapOvr>
+</p:sld>
+</file>
+
+<file path=ppt/slides/slide17.xml><?xml version="1.0" encoding="utf-8"?>
+<p:sld xmlns:a="http://schemas.openxmlformats.org/drawingml/2006/main" xmlns:p="http://schemas.openxmlformats.org/presentationml/2006/main" xmlns:r="http://schemas.openxmlformats.org/officeDocument/2006/relationships">
+  <p:cSld>
+    <p:bg>
+      <p:bgPr>
+        <a:solidFill>
+          <a:srgbClr val="FFFFFF"/>
+        </a:solidFill>
+        <a:effectLst/>
+      </p:bgPr>
+    </p:bg>
+    <p:spTree>
+      <p:nvGrpSpPr>
+        <p:cNvPr id="1" name=""/>
+        <p:cNvGrpSpPr/>
+        <p:nvPr/>
+      </p:nvGrpSpPr>
+      <p:grpSpPr/>
+      <p:sp>
+        <p:nvSpPr>
+          <p:cNvPr id="2" name="Shape 0"/>
+          <p:cNvSpPr/>
+          <p:nvPr/>
+        </p:nvSpPr>
+        <p:spPr>
+          <a:xfrm>
+            <a:off x="0" y="0"/>
+            <a:ext cx="9144000" cy="502920"/>
+          </a:xfrm>
+          <a:prstGeom prst="rect">
+            <a:avLst/>
+          </a:prstGeom>
+          <a:solidFill>
+            <a:srgbClr val="1B3A5C"/>
+          </a:solidFill>
+          <a:ln/>
+        </p:spPr>
+        <p:txBody>
+          <a:bodyPr/>
+          <a:lstStyle/>
+          <a:p>
+            <a:pPr algn="ctr"/>
+            <a:endParaRPr lang="fr-FR" dirty="0"/>
+          </a:p>
+        </p:txBody>
+      </p:sp>
+      <p:sp>
+        <p:nvSpPr>
+          <p:cNvPr id="3" name="Text 1"/>
+          <p:cNvSpPr/>
+          <p:nvPr/>
+        </p:nvSpPr>
+        <p:spPr>
+          <a:xfrm>
+            <a:off x="274320" y="82296"/>
+            <a:ext cx="8412480" cy="338328"/>
+          </a:xfrm>
+          <a:prstGeom prst="rect">
+            <a:avLst/>
+          </a:prstGeom>
+          <a:noFill/>
+          <a:ln/>
+        </p:spPr>
+        <p:txBody>
+          <a:bodyPr wrap="square" lIns="0" tIns="0" rIns="0" bIns="0" rtlCol="0" anchor="ctr"/>
+          <a:lstStyle/>
+          <a:p>
+            <a:pPr marL="0" indent="0" algn="ctr">
+              <a:buNone/>
+            </a:pPr>
+            <a:r>
+              <a:rPr lang="en-US" sz="3600" b="1" dirty="0">
+                <a:solidFill>
+                  <a:srgbClr val="FFFFFF"/>
+                </a:solidFill>
+              </a:rPr>
+              <a:t>Sommaire</a:t>
+            </a:r>
+            <a:endParaRPr lang="en-US" sz="3600" dirty="0"/>
+          </a:p>
+        </p:txBody>
+      </p:sp>
+      <p:sp>
+        <p:nvSpPr>
+          <p:cNvPr id="4" name="Shape 2"/>
+          <p:cNvSpPr/>
+          <p:nvPr/>
+        </p:nvSpPr>
+        <p:spPr>
+          <a:xfrm>
+            <a:off x="0" y="502920"/>
+            <a:ext cx="54864" cy="4636008"/>
+          </a:xfrm>
+          <a:prstGeom prst="rect">
+            <a:avLst/>
+          </a:prstGeom>
+          <a:solidFill>
+            <a:srgbClr val="00B4D8"/>
+          </a:solidFill>
+          <a:ln/>
+        </p:spPr>
+      </p:sp>
+      <p:sp>
+        <p:nvSpPr>
+          <p:cNvPr id="5" name="Text 3"/>
+          <p:cNvSpPr/>
+          <p:nvPr/>
+        </p:nvSpPr>
+        <p:spPr>
+          <a:xfrm>
+            <a:off x="182880" y="4892040"/>
+            <a:ext cx="8686800" cy="201168"/>
+          </a:xfrm>
+          <a:prstGeom prst="rect">
+            <a:avLst/>
+          </a:prstGeom>
+          <a:noFill/>
+          <a:ln/>
+        </p:spPr>
+        <p:txBody>
+          <a:bodyPr wrap="square" rtlCol="0" anchor="ctr"/>
+          <a:lstStyle/>
+          <a:p>
+            <a:pPr marL="0" indent="0" algn="l">
+              <a:buNone/>
+            </a:pPr>
+            <a:r>
+              <a:rPr lang="en-US" sz="800" dirty="0" err="1">
+                <a:solidFill>
+                  <a:srgbClr val="8BAAC5"/>
+                </a:solidFill>
+              </a:rPr>
+              <a:t>Automatisation</a:t>
+            </a:r>
+            <a:r>
+              <a:rPr lang="en-US" sz="800" dirty="0">
+                <a:solidFill>
+                  <a:srgbClr val="8BAAC5"/>
+                </a:solidFill>
+              </a:rPr>
+              <a:t> de la Supervision et de la </a:t>
+            </a:r>
+            <a:r>
+              <a:rPr lang="en-US" sz="800" dirty="0" err="1">
+                <a:solidFill>
+                  <a:srgbClr val="8BAAC5"/>
+                </a:solidFill>
+              </a:rPr>
+              <a:t>Détection</a:t>
+            </a:r>
+            <a:r>
+              <a:rPr lang="en-US" sz="800" dirty="0">
+                <a:solidFill>
+                  <a:srgbClr val="8BAAC5"/>
+                </a:solidFill>
+              </a:rPr>
+              <a:t> des </a:t>
+            </a:r>
+            <a:r>
+              <a:rPr lang="en-US" sz="800" dirty="0" err="1">
+                <a:solidFill>
+                  <a:srgbClr val="8BAAC5"/>
+                </a:solidFill>
+              </a:rPr>
+              <a:t>Pannes</a:t>
+            </a:r>
+            <a:r>
+              <a:rPr lang="en-US" sz="800" dirty="0">
+                <a:solidFill>
+                  <a:srgbClr val="8BAAC5"/>
+                </a:solidFill>
+              </a:rPr>
+              <a:t> Réseau — OPEN</a:t>
+            </a:r>
+            <a:endParaRPr lang="en-US" sz="800" dirty="0"/>
+          </a:p>
+        </p:txBody>
+      </p:sp>
+      <p:sp>
+        <p:nvSpPr>
+          <p:cNvPr id="6" name="TextBox 5"/>
+          <p:cNvSpPr txBox="1"/>
+          <p:nvPr/>
+        </p:nvSpPr>
+        <p:spPr>
+          <a:xfrm>
+            <a:off x="274320" y="603504"/>
+            <a:ext cx="8412480" cy="292608"/>
+          </a:xfrm>
+          <a:prstGeom prst="rect">
+            <a:avLst/>
+          </a:prstGeom>
+          <a:noFill/>
+        </p:spPr>
+        <p:txBody>
+          <a:bodyPr wrap="none">
+            <a:spAutoFit/>
+          </a:bodyPr>
+          <a:lstStyle/>
+          <a:p>
+            <a:r>
+              <a:rPr sz="1300" b="1" i="1">
+                <a:solidFill>
+                  <a:srgbClr val="00B4D8"/>
+                </a:solidFill>
+              </a:rPr>
+              <a:t>Plan de la présentation</a:t>
+            </a:r>
+          </a:p>
+        </p:txBody>
+      </p:sp>
+      <p:sp>
+        <p:nvSpPr>
+          <p:cNvPr id="7" name="Rounded Rectangle 6"/>
+          <p:cNvSpPr/>
+          <p:nvPr/>
+        </p:nvSpPr>
+        <p:spPr>
+          <a:xfrm>
+            <a:off x="411480" y="1078992"/>
+            <a:ext cx="329184" cy="329184"/>
+          </a:xfrm>
+          <a:prstGeom prst="roundRect">
+            <a:avLst>
+              <a:gd name="adj" fmla="val 18000"/>
+            </a:avLst>
+          </a:prstGeom>
+          <a:solidFill>
+            <a:srgbClr val="00B4D8"/>
+          </a:solidFill>
+          <a:ln>
+            <a:noFill/>
+          </a:ln>
+          <a:effectLst/>
+        </p:spPr>
+        <p:style>
+          <a:lnRef idx="1">
+            <a:schemeClr val="accent1"/>
+          </a:lnRef>
+          <a:fillRef idx="3">
+            <a:schemeClr val="accent1"/>
+          </a:fillRef>
+          <a:effectRef idx="2">
+            <a:schemeClr val="accent1"/>
+          </a:effectRef>
+          <a:fontRef idx="minor">
+            <a:schemeClr val="lt1"/>
+          </a:fontRef>
+        </p:style>
+        <p:txBody>
+          <a:bodyPr rtlCol="0" anchor="ctr" wrap="none" lIns="0" rIns="0" tIns="0" bIns="0"/>
+          <a:lstStyle/>
+          <a:p>
+            <a:pPr algn="ctr"/>
+            <a:r>
+              <a:rPr sz="1600" b="1">
+                <a:solidFill>
+                  <a:srgbClr val="FFFFFF"/>
+                </a:solidFill>
+              </a:rPr>
+              <a:t>•</a:t>
+            </a:r>
+          </a:p>
+        </p:txBody>
+      </p:sp>
+      <p:sp>
+        <p:nvSpPr>
+          <p:cNvPr id="8" name="TextBox 7"/>
+          <p:cNvSpPr txBox="1"/>
+          <p:nvPr/>
+        </p:nvSpPr>
+        <p:spPr>
+          <a:xfrm>
+            <a:off x="868680" y="1058992"/>
+            <a:ext cx="3703320" cy="384048"/>
+          </a:xfrm>
+          <a:prstGeom prst="rect">
+            <a:avLst/>
+          </a:prstGeom>
+          <a:noFill/>
+        </p:spPr>
+        <p:txBody>
+          <a:bodyPr wrap="square" anchor="ctr">
+            <a:spAutoFit/>
+          </a:bodyPr>
+          <a:lstStyle/>
+          <a:p>
+            <a:r>
+              <a:rPr sz="1350" b="1">
+                <a:solidFill>
+                  <a:srgbClr val="1B3A5C"/>
+                </a:solidFill>
+              </a:rPr>
+              <a:t>Introduction</a:t>
+            </a:r>
+          </a:p>
+        </p:txBody>
+      </p:sp>
+      <p:sp>
+        <p:nvSpPr>
+          <p:cNvPr id="9" name="Rounded Rectangle 8"/>
+          <p:cNvSpPr/>
+          <p:nvPr/>
+        </p:nvSpPr>
+        <p:spPr>
+          <a:xfrm>
+            <a:off x="411480" y="1549908"/>
+            <a:ext cx="329184" cy="329184"/>
+          </a:xfrm>
+          <a:prstGeom prst="roundRect">
+            <a:avLst>
+              <a:gd name="adj" fmla="val 18000"/>
+            </a:avLst>
+          </a:prstGeom>
+          <a:solidFill>
+            <a:srgbClr val="00B4D8"/>
+          </a:solidFill>
+          <a:ln>
+            <a:noFill/>
+          </a:ln>
+          <a:effectLst/>
+        </p:spPr>
+        <p:style>
+          <a:lnRef idx="1">
+            <a:schemeClr val="accent1"/>
+          </a:lnRef>
+          <a:fillRef idx="3">
+            <a:schemeClr val="accent1"/>
+          </a:fillRef>
+          <a:effectRef idx="2">
+            <a:schemeClr val="accent1"/>
+          </a:effectRef>
+          <a:fontRef idx="minor">
+            <a:schemeClr val="lt1"/>
+          </a:fontRef>
+        </p:style>
+        <p:txBody>
+          <a:bodyPr rtlCol="0" anchor="ctr" wrap="none" lIns="0" rIns="0" tIns="0" bIns="0"/>
+          <a:lstStyle/>
+          <a:p>
+            <a:pPr algn="ctr"/>
+            <a:r>
+              <a:rPr sz="1600" b="1">
+                <a:solidFill>
+                  <a:srgbClr val="FFFFFF"/>
+                </a:solidFill>
+              </a:rPr>
+              <a:t>•</a:t>
+            </a:r>
+          </a:p>
+        </p:txBody>
+      </p:sp>
+      <p:sp>
+        <p:nvSpPr>
+          <p:cNvPr id="10" name="TextBox 9"/>
+          <p:cNvSpPr txBox="1"/>
+          <p:nvPr/>
+        </p:nvSpPr>
+        <p:spPr>
+          <a:xfrm>
+            <a:off x="868680" y="1529908"/>
+            <a:ext cx="3703320" cy="384048"/>
+          </a:xfrm>
+          <a:prstGeom prst="rect">
+            <a:avLst/>
+          </a:prstGeom>
+          <a:noFill/>
+        </p:spPr>
+        <p:txBody>
+          <a:bodyPr wrap="square" anchor="ctr">
+            <a:spAutoFit/>
+          </a:bodyPr>
+          <a:lstStyle/>
+          <a:p>
+            <a:r>
+              <a:rPr sz="1350" b="1">
+                <a:solidFill>
+                  <a:srgbClr val="1B3A5C"/>
+                </a:solidFill>
+              </a:rPr>
+              <a:t>Problématique</a:t>
+            </a:r>
+          </a:p>
+        </p:txBody>
+      </p:sp>
+      <p:sp>
+        <p:nvSpPr>
+          <p:cNvPr id="11" name="Rounded Rectangle 10"/>
+          <p:cNvSpPr/>
+          <p:nvPr/>
+        </p:nvSpPr>
+        <p:spPr>
+          <a:xfrm>
+            <a:off x="411480" y="2020824"/>
+            <a:ext cx="329184" cy="329184"/>
+          </a:xfrm>
+          <a:prstGeom prst="roundRect">
+            <a:avLst>
+              <a:gd name="adj" fmla="val 18000"/>
+            </a:avLst>
+          </a:prstGeom>
+          <a:solidFill>
+            <a:srgbClr val="00B4D8"/>
+          </a:solidFill>
+          <a:ln>
+            <a:noFill/>
+          </a:ln>
+          <a:effectLst/>
+        </p:spPr>
+        <p:style>
+          <a:lnRef idx="1">
+            <a:schemeClr val="accent1"/>
+          </a:lnRef>
+          <a:fillRef idx="3">
+            <a:schemeClr val="accent1"/>
+          </a:fillRef>
+          <a:effectRef idx="2">
+            <a:schemeClr val="accent1"/>
+          </a:effectRef>
+          <a:fontRef idx="minor">
+            <a:schemeClr val="lt1"/>
+          </a:fontRef>
+        </p:style>
+        <p:txBody>
+          <a:bodyPr rtlCol="0" anchor="ctr" wrap="none" lIns="0" rIns="0" tIns="0" bIns="0"/>
+          <a:lstStyle/>
+          <a:p>
+            <a:pPr algn="ctr"/>
+            <a:r>
+              <a:rPr sz="1300" b="1">
+                <a:solidFill>
+                  <a:srgbClr val="FFFFFF"/>
+                </a:solidFill>
+              </a:rPr>
+              <a:t>1</a:t>
+            </a:r>
+          </a:p>
+        </p:txBody>
+      </p:sp>
+      <p:sp>
+        <p:nvSpPr>
+          <p:cNvPr id="12" name="TextBox 11"/>
+          <p:cNvSpPr txBox="1"/>
+          <p:nvPr/>
+        </p:nvSpPr>
+        <p:spPr>
+          <a:xfrm>
+            <a:off x="868680" y="2000824"/>
+            <a:ext cx="3703320" cy="384048"/>
+          </a:xfrm>
+          <a:prstGeom prst="rect">
+            <a:avLst/>
+          </a:prstGeom>
+          <a:noFill/>
+        </p:spPr>
+        <p:txBody>
+          <a:bodyPr wrap="square" anchor="ctr">
+            <a:spAutoFit/>
+          </a:bodyPr>
+          <a:lstStyle/>
+          <a:p>
+            <a:r>
+              <a:rPr sz="1350" b="0">
+                <a:solidFill>
+                  <a:srgbClr val="1B3A5C"/>
+                </a:solidFill>
+              </a:rPr>
+              <a:t>Contexte &amp; identification du problème</a:t>
+            </a:r>
+          </a:p>
+        </p:txBody>
+      </p:sp>
+      <p:sp>
+        <p:nvSpPr>
+          <p:cNvPr id="13" name="Rounded Rectangle 12"/>
+          <p:cNvSpPr/>
+          <p:nvPr/>
+        </p:nvSpPr>
+        <p:spPr>
+          <a:xfrm>
+            <a:off x="411480" y="2491740"/>
+            <a:ext cx="329184" cy="329184"/>
+          </a:xfrm>
+          <a:prstGeom prst="roundRect">
+            <a:avLst>
+              <a:gd name="adj" fmla="val 18000"/>
+            </a:avLst>
+          </a:prstGeom>
+          <a:solidFill>
+            <a:srgbClr val="00B4D8"/>
+          </a:solidFill>
+          <a:ln>
+            <a:noFill/>
+          </a:ln>
+          <a:effectLst/>
+        </p:spPr>
+        <p:style>
+          <a:lnRef idx="1">
+            <a:schemeClr val="accent1"/>
+          </a:lnRef>
+          <a:fillRef idx="3">
+            <a:schemeClr val="accent1"/>
+          </a:fillRef>
+          <a:effectRef idx="2">
+            <a:schemeClr val="accent1"/>
+          </a:effectRef>
+          <a:fontRef idx="minor">
+            <a:schemeClr val="lt1"/>
+          </a:fontRef>
+        </p:style>
+        <p:txBody>
+          <a:bodyPr rtlCol="0" anchor="ctr" wrap="none" lIns="0" rIns="0" tIns="0" bIns="0"/>
+          <a:lstStyle/>
+          <a:p>
+            <a:pPr algn="ctr"/>
+            <a:r>
+              <a:rPr sz="1300" b="1">
+                <a:solidFill>
+                  <a:srgbClr val="FFFFFF"/>
+                </a:solidFill>
+              </a:rPr>
+              <a:t>2</a:t>
+            </a:r>
+          </a:p>
+        </p:txBody>
+      </p:sp>
+      <p:sp>
+        <p:nvSpPr>
+          <p:cNvPr id="14" name="TextBox 13"/>
+          <p:cNvSpPr txBox="1"/>
+          <p:nvPr/>
+        </p:nvSpPr>
+        <p:spPr>
+          <a:xfrm>
+            <a:off x="868680" y="2471740"/>
+            <a:ext cx="3703320" cy="384048"/>
+          </a:xfrm>
+          <a:prstGeom prst="rect">
+            <a:avLst/>
+          </a:prstGeom>
+          <a:noFill/>
+        </p:spPr>
+        <p:txBody>
+          <a:bodyPr wrap="square" anchor="ctr">
+            <a:spAutoFit/>
+          </a:bodyPr>
+          <a:lstStyle/>
+          <a:p>
+            <a:r>
+              <a:rPr sz="1350" b="0">
+                <a:solidFill>
+                  <a:srgbClr val="1B3A5C"/>
+                </a:solidFill>
+              </a:rPr>
+              <a:t>Objectifs du projet</a:t>
+            </a:r>
+          </a:p>
+        </p:txBody>
+      </p:sp>
+      <p:sp>
+        <p:nvSpPr>
+          <p:cNvPr id="15" name="Rounded Rectangle 14"/>
+          <p:cNvSpPr/>
+          <p:nvPr/>
+        </p:nvSpPr>
+        <p:spPr>
+          <a:xfrm>
+            <a:off x="411480" y="2962656"/>
+            <a:ext cx="329184" cy="329184"/>
+          </a:xfrm>
+          <a:prstGeom prst="roundRect">
+            <a:avLst>
+              <a:gd name="adj" fmla="val 18000"/>
+            </a:avLst>
+          </a:prstGeom>
+          <a:solidFill>
+            <a:srgbClr val="00B4D8"/>
+          </a:solidFill>
+          <a:ln>
+            <a:noFill/>
+          </a:ln>
+          <a:effectLst/>
+        </p:spPr>
+        <p:style>
+          <a:lnRef idx="1">
+            <a:schemeClr val="accent1"/>
+          </a:lnRef>
+          <a:fillRef idx="3">
+            <a:schemeClr val="accent1"/>
+          </a:fillRef>
+          <a:effectRef idx="2">
+            <a:schemeClr val="accent1"/>
+          </a:effectRef>
+          <a:fontRef idx="minor">
+            <a:schemeClr val="lt1"/>
+          </a:fontRef>
+        </p:style>
+        <p:txBody>
+          <a:bodyPr rtlCol="0" anchor="ctr" wrap="none" lIns="0" rIns="0" tIns="0" bIns="0"/>
+          <a:lstStyle/>
+          <a:p>
+            <a:pPr algn="ctr"/>
+            <a:r>
+              <a:rPr sz="1300" b="1">
+                <a:solidFill>
+                  <a:srgbClr val="FFFFFF"/>
+                </a:solidFill>
+              </a:rPr>
+              <a:t>3</a:t>
+            </a:r>
+          </a:p>
+        </p:txBody>
+      </p:sp>
+      <p:sp>
+        <p:nvSpPr>
+          <p:cNvPr id="16" name="TextBox 15"/>
+          <p:cNvSpPr txBox="1"/>
+          <p:nvPr/>
+        </p:nvSpPr>
+        <p:spPr>
+          <a:xfrm>
+            <a:off x="868680" y="2942656"/>
+            <a:ext cx="3703320" cy="384048"/>
+          </a:xfrm>
+          <a:prstGeom prst="rect">
+            <a:avLst/>
+          </a:prstGeom>
+          <a:noFill/>
+        </p:spPr>
+        <p:txBody>
+          <a:bodyPr wrap="square" anchor="ctr">
+            <a:spAutoFit/>
+          </a:bodyPr>
+          <a:lstStyle/>
+          <a:p>
+            <a:r>
+              <a:rPr sz="1350" b="0">
+                <a:solidFill>
+                  <a:srgbClr val="1B3A5C"/>
+                </a:solidFill>
+              </a:rPr>
+              <a:t>Démarche méthodologique</a:t>
+            </a:r>
+          </a:p>
+        </p:txBody>
+      </p:sp>
+      <p:sp>
+        <p:nvSpPr>
+          <p:cNvPr id="17" name="Rounded Rectangle 16"/>
+          <p:cNvSpPr/>
+          <p:nvPr/>
+        </p:nvSpPr>
+        <p:spPr>
+          <a:xfrm>
+            <a:off x="411480" y="3433572"/>
+            <a:ext cx="329184" cy="329184"/>
+          </a:xfrm>
+          <a:prstGeom prst="roundRect">
+            <a:avLst>
+              <a:gd name="adj" fmla="val 18000"/>
+            </a:avLst>
+          </a:prstGeom>
+          <a:solidFill>
+            <a:srgbClr val="00B4D8"/>
+          </a:solidFill>
+          <a:ln>
+            <a:noFill/>
+          </a:ln>
+          <a:effectLst/>
+        </p:spPr>
+        <p:style>
+          <a:lnRef idx="1">
+            <a:schemeClr val="accent1"/>
+          </a:lnRef>
+          <a:fillRef idx="3">
+            <a:schemeClr val="accent1"/>
+          </a:fillRef>
+          <a:effectRef idx="2">
+            <a:schemeClr val="accent1"/>
+          </a:effectRef>
+          <a:fontRef idx="minor">
+            <a:schemeClr val="lt1"/>
+          </a:fontRef>
+        </p:style>
+        <p:txBody>
+          <a:bodyPr rtlCol="0" anchor="ctr" wrap="none" lIns="0" rIns="0" tIns="0" bIns="0"/>
+          <a:lstStyle/>
+          <a:p>
+            <a:pPr algn="ctr"/>
+            <a:r>
+              <a:rPr sz="1300" b="1">
+                <a:solidFill>
+                  <a:srgbClr val="FFFFFF"/>
+                </a:solidFill>
+              </a:rPr>
+              <a:t>4</a:t>
+            </a:r>
+          </a:p>
+        </p:txBody>
+      </p:sp>
+      <p:sp>
+        <p:nvSpPr>
+          <p:cNvPr id="18" name="TextBox 17"/>
+          <p:cNvSpPr txBox="1"/>
+          <p:nvPr/>
+        </p:nvSpPr>
+        <p:spPr>
+          <a:xfrm>
+            <a:off x="868680" y="3413572"/>
+            <a:ext cx="3703320" cy="384048"/>
+          </a:xfrm>
+          <a:prstGeom prst="rect">
+            <a:avLst/>
+          </a:prstGeom>
+          <a:noFill/>
+        </p:spPr>
+        <p:txBody>
+          <a:bodyPr wrap="square" anchor="ctr">
+            <a:spAutoFit/>
+          </a:bodyPr>
+          <a:lstStyle/>
+          <a:p>
+            <a:r>
+              <a:rPr sz="1350" b="0">
+                <a:solidFill>
+                  <a:srgbClr val="1B3A5C"/>
+                </a:solidFill>
+              </a:rPr>
+              <a:t>État des lieux — Solutions existantes</a:t>
+            </a:r>
+          </a:p>
+        </p:txBody>
+      </p:sp>
+      <p:sp>
+        <p:nvSpPr>
+          <p:cNvPr id="19" name="Rounded Rectangle 18"/>
+          <p:cNvSpPr/>
+          <p:nvPr/>
+        </p:nvSpPr>
+        <p:spPr>
+          <a:xfrm>
+            <a:off x="411480" y="3904488"/>
+            <a:ext cx="329184" cy="329184"/>
+          </a:xfrm>
+          <a:prstGeom prst="roundRect">
+            <a:avLst>
+              <a:gd name="adj" fmla="val 18000"/>
+            </a:avLst>
+          </a:prstGeom>
+          <a:solidFill>
+            <a:srgbClr val="00B4D8"/>
+          </a:solidFill>
+          <a:ln>
+            <a:noFill/>
+          </a:ln>
+          <a:effectLst/>
+        </p:spPr>
+        <p:style>
+          <a:lnRef idx="1">
+            <a:schemeClr val="accent1"/>
+          </a:lnRef>
+          <a:fillRef idx="3">
+            <a:schemeClr val="accent1"/>
+          </a:fillRef>
+          <a:effectRef idx="2">
+            <a:schemeClr val="accent1"/>
+          </a:effectRef>
+          <a:fontRef idx="minor">
+            <a:schemeClr val="lt1"/>
+          </a:fontRef>
+        </p:style>
+        <p:txBody>
+          <a:bodyPr rtlCol="0" anchor="ctr" wrap="none" lIns="0" rIns="0" tIns="0" bIns="0"/>
+          <a:lstStyle/>
+          <a:p>
+            <a:pPr algn="ctr"/>
+            <a:r>
+              <a:rPr sz="1300" b="1">
+                <a:solidFill>
+                  <a:srgbClr val="FFFFFF"/>
+                </a:solidFill>
+              </a:rPr>
+              <a:t>5</a:t>
+            </a:r>
+          </a:p>
+        </p:txBody>
+      </p:sp>
+      <p:sp>
+        <p:nvSpPr>
+          <p:cNvPr id="20" name="TextBox 19"/>
+          <p:cNvSpPr txBox="1"/>
+          <p:nvPr/>
+        </p:nvSpPr>
+        <p:spPr>
+          <a:xfrm>
+            <a:off x="868680" y="3884488"/>
+            <a:ext cx="3703320" cy="384048"/>
+          </a:xfrm>
+          <a:prstGeom prst="rect">
+            <a:avLst/>
+          </a:prstGeom>
+          <a:noFill/>
+        </p:spPr>
+        <p:txBody>
+          <a:bodyPr wrap="square" anchor="ctr">
+            <a:spAutoFit/>
+          </a:bodyPr>
+          <a:lstStyle/>
+          <a:p>
+            <a:r>
+              <a:rPr sz="1350" b="0">
+                <a:solidFill>
+                  <a:srgbClr val="1B3A5C"/>
+                </a:solidFill>
+              </a:rPr>
+              <a:t>AWALI — Architecture &amp; différenciation</a:t>
+            </a:r>
+          </a:p>
+        </p:txBody>
+      </p:sp>
+      <p:sp>
+        <p:nvSpPr>
+          <p:cNvPr id="21" name="Rounded Rectangle 20"/>
+          <p:cNvSpPr/>
+          <p:nvPr/>
+        </p:nvSpPr>
+        <p:spPr>
+          <a:xfrm>
+            <a:off x="411480" y="4375404"/>
+            <a:ext cx="329184" cy="329184"/>
+          </a:xfrm>
+          <a:prstGeom prst="roundRect">
+            <a:avLst>
+              <a:gd name="adj" fmla="val 18000"/>
+            </a:avLst>
+          </a:prstGeom>
+          <a:solidFill>
+            <a:srgbClr val="00B4D8"/>
+          </a:solidFill>
+          <a:ln>
+            <a:noFill/>
+          </a:ln>
+          <a:effectLst/>
+        </p:spPr>
+        <p:style>
+          <a:lnRef idx="1">
+            <a:schemeClr val="accent1"/>
+          </a:lnRef>
+          <a:fillRef idx="3">
+            <a:schemeClr val="accent1"/>
+          </a:fillRef>
+          <a:effectRef idx="2">
+            <a:schemeClr val="accent1"/>
+          </a:effectRef>
+          <a:fontRef idx="minor">
+            <a:schemeClr val="lt1"/>
+          </a:fontRef>
+        </p:style>
+        <p:txBody>
+          <a:bodyPr rtlCol="0" anchor="ctr" wrap="none" lIns="0" rIns="0" tIns="0" bIns="0"/>
+          <a:lstStyle/>
+          <a:p>
+            <a:pPr algn="ctr"/>
+            <a:r>
+              <a:rPr sz="1300" b="1">
+                <a:solidFill>
+                  <a:srgbClr val="FFFFFF"/>
+                </a:solidFill>
+              </a:rPr>
+              <a:t>6</a:t>
+            </a:r>
+          </a:p>
+        </p:txBody>
+      </p:sp>
+      <p:sp>
+        <p:nvSpPr>
+          <p:cNvPr id="22" name="TextBox 21"/>
+          <p:cNvSpPr txBox="1"/>
+          <p:nvPr/>
+        </p:nvSpPr>
+        <p:spPr>
+          <a:xfrm>
+            <a:off x="868680" y="4355404"/>
+            <a:ext cx="3703320" cy="384048"/>
+          </a:xfrm>
+          <a:prstGeom prst="rect">
+            <a:avLst/>
+          </a:prstGeom>
+          <a:noFill/>
+        </p:spPr>
+        <p:txBody>
+          <a:bodyPr wrap="square" anchor="ctr">
+            <a:spAutoFit/>
+          </a:bodyPr>
+          <a:lstStyle/>
+          <a:p>
+            <a:r>
+              <a:rPr sz="1350" b="0">
+                <a:solidFill>
+                  <a:srgbClr val="1B3A5C"/>
+                </a:solidFill>
+              </a:rPr>
+              <a:t>Étude de faisabilité &amp; conception</a:t>
+            </a:r>
+          </a:p>
+        </p:txBody>
+      </p:sp>
+      <p:sp>
+        <p:nvSpPr>
+          <p:cNvPr id="23" name="Rounded Rectangle 22"/>
+          <p:cNvSpPr/>
+          <p:nvPr/>
+        </p:nvSpPr>
+        <p:spPr>
+          <a:xfrm>
+            <a:off x="4709160" y="1078992"/>
+            <a:ext cx="329184" cy="329184"/>
+          </a:xfrm>
+          <a:prstGeom prst="roundRect">
+            <a:avLst>
+              <a:gd name="adj" fmla="val 18000"/>
+            </a:avLst>
+          </a:prstGeom>
+          <a:solidFill>
+            <a:srgbClr val="00B4D8"/>
+          </a:solidFill>
+          <a:ln>
+            <a:noFill/>
+          </a:ln>
+          <a:effectLst/>
+        </p:spPr>
+        <p:style>
+          <a:lnRef idx="1">
+            <a:schemeClr val="accent1"/>
+          </a:lnRef>
+          <a:fillRef idx="3">
+            <a:schemeClr val="accent1"/>
+          </a:fillRef>
+          <a:effectRef idx="2">
+            <a:schemeClr val="accent1"/>
+          </a:effectRef>
+          <a:fontRef idx="minor">
+            <a:schemeClr val="lt1"/>
+          </a:fontRef>
+        </p:style>
+        <p:txBody>
+          <a:bodyPr rtlCol="0" anchor="ctr" wrap="none" lIns="0" rIns="0" tIns="0" bIns="0"/>
+          <a:lstStyle/>
+          <a:p>
+            <a:pPr algn="ctr"/>
+            <a:r>
+              <a:rPr sz="1300" b="1">
+                <a:solidFill>
+                  <a:srgbClr val="FFFFFF"/>
+                </a:solidFill>
+              </a:rPr>
+              <a:t>7</a:t>
+            </a:r>
+          </a:p>
+        </p:txBody>
+      </p:sp>
+      <p:sp>
+        <p:nvSpPr>
+          <p:cNvPr id="24" name="TextBox 23"/>
+          <p:cNvSpPr txBox="1"/>
+          <p:nvPr/>
+        </p:nvSpPr>
+        <p:spPr>
+          <a:xfrm>
+            <a:off x="5166360" y="1058992"/>
+            <a:ext cx="3749039" cy="384048"/>
+          </a:xfrm>
+          <a:prstGeom prst="rect">
+            <a:avLst/>
+          </a:prstGeom>
+          <a:noFill/>
+        </p:spPr>
+        <p:txBody>
+          <a:bodyPr wrap="square" anchor="ctr">
+            <a:spAutoFit/>
+          </a:bodyPr>
+          <a:lstStyle/>
+          <a:p>
+            <a:r>
+              <a:rPr sz="1350" b="0">
+                <a:solidFill>
+                  <a:srgbClr val="1B3A5C"/>
+                </a:solidFill>
+              </a:rPr>
+              <a:t>Conception — UML &amp; MERISE</a:t>
+            </a:r>
+          </a:p>
+        </p:txBody>
+      </p:sp>
+      <p:sp>
+        <p:nvSpPr>
+          <p:cNvPr id="25" name="Rounded Rectangle 24"/>
+          <p:cNvSpPr/>
+          <p:nvPr/>
+        </p:nvSpPr>
+        <p:spPr>
+          <a:xfrm>
+            <a:off x="4709160" y="1549908"/>
+            <a:ext cx="329184" cy="329184"/>
+          </a:xfrm>
+          <a:prstGeom prst="roundRect">
+            <a:avLst>
+              <a:gd name="adj" fmla="val 18000"/>
+            </a:avLst>
+          </a:prstGeom>
+          <a:solidFill>
+            <a:srgbClr val="00B4D8"/>
+          </a:solidFill>
+          <a:ln>
+            <a:noFill/>
+          </a:ln>
+          <a:effectLst/>
+        </p:spPr>
+        <p:style>
+          <a:lnRef idx="1">
+            <a:schemeClr val="accent1"/>
+          </a:lnRef>
+          <a:fillRef idx="3">
+            <a:schemeClr val="accent1"/>
+          </a:fillRef>
+          <a:effectRef idx="2">
+            <a:schemeClr val="accent1"/>
+          </a:effectRef>
+          <a:fontRef idx="minor">
+            <a:schemeClr val="lt1"/>
+          </a:fontRef>
+        </p:style>
+        <p:txBody>
+          <a:bodyPr rtlCol="0" anchor="ctr" wrap="none" lIns="0" rIns="0" tIns="0" bIns="0"/>
+          <a:lstStyle/>
+          <a:p>
+            <a:pPr algn="ctr"/>
+            <a:r>
+              <a:rPr sz="1300" b="1">
+                <a:solidFill>
+                  <a:srgbClr val="FFFFFF"/>
+                </a:solidFill>
+              </a:rPr>
+              <a:t>8</a:t>
+            </a:r>
+          </a:p>
+        </p:txBody>
+      </p:sp>
+      <p:sp>
+        <p:nvSpPr>
+          <p:cNvPr id="26" name="TextBox 25"/>
+          <p:cNvSpPr txBox="1"/>
+          <p:nvPr/>
+        </p:nvSpPr>
+        <p:spPr>
+          <a:xfrm>
+            <a:off x="5166360" y="1529908"/>
+            <a:ext cx="3749039" cy="384048"/>
+          </a:xfrm>
+          <a:prstGeom prst="rect">
+            <a:avLst/>
+          </a:prstGeom>
+          <a:noFill/>
+        </p:spPr>
+        <p:txBody>
+          <a:bodyPr wrap="square" anchor="ctr">
+            <a:spAutoFit/>
+          </a:bodyPr>
+          <a:lstStyle/>
+          <a:p>
+            <a:r>
+              <a:rPr sz="1350" b="0">
+                <a:solidFill>
+                  <a:srgbClr val="1B3A5C"/>
+                </a:solidFill>
+              </a:rPr>
+              <a:t>Fonctionnement — Pipeline technique</a:t>
+            </a:r>
+          </a:p>
+        </p:txBody>
+      </p:sp>
+      <p:sp>
+        <p:nvSpPr>
+          <p:cNvPr id="27" name="Rounded Rectangle 26"/>
+          <p:cNvSpPr/>
+          <p:nvPr/>
+        </p:nvSpPr>
+        <p:spPr>
+          <a:xfrm>
+            <a:off x="4709160" y="2020824"/>
+            <a:ext cx="329184" cy="329184"/>
+          </a:xfrm>
+          <a:prstGeom prst="roundRect">
+            <a:avLst>
+              <a:gd name="adj" fmla="val 18000"/>
+            </a:avLst>
+          </a:prstGeom>
+          <a:solidFill>
+            <a:srgbClr val="00B4D8"/>
+          </a:solidFill>
+          <a:ln>
+            <a:noFill/>
+          </a:ln>
+          <a:effectLst/>
+        </p:spPr>
+        <p:style>
+          <a:lnRef idx="1">
+            <a:schemeClr val="accent1"/>
+          </a:lnRef>
+          <a:fillRef idx="3">
+            <a:schemeClr val="accent1"/>
+          </a:fillRef>
+          <a:effectRef idx="2">
+            <a:schemeClr val="accent1"/>
+          </a:effectRef>
+          <a:fontRef idx="minor">
+            <a:schemeClr val="lt1"/>
+          </a:fontRef>
+        </p:style>
+        <p:txBody>
+          <a:bodyPr rtlCol="0" anchor="ctr" wrap="none" lIns="0" rIns="0" tIns="0" bIns="0"/>
+          <a:lstStyle/>
+          <a:p>
+            <a:pPr algn="ctr"/>
+            <a:r>
+              <a:rPr sz="1300" b="1">
+                <a:solidFill>
+                  <a:srgbClr val="FFFFFF"/>
+                </a:solidFill>
+              </a:rPr>
+              <a:t>9</a:t>
+            </a:r>
+          </a:p>
+        </p:txBody>
+      </p:sp>
+      <p:sp>
+        <p:nvSpPr>
+          <p:cNvPr id="28" name="TextBox 27"/>
+          <p:cNvSpPr txBox="1"/>
+          <p:nvPr/>
+        </p:nvSpPr>
+        <p:spPr>
+          <a:xfrm>
+            <a:off x="5166360" y="2000824"/>
+            <a:ext cx="3749039" cy="384048"/>
+          </a:xfrm>
+          <a:prstGeom prst="rect">
+            <a:avLst/>
+          </a:prstGeom>
+          <a:noFill/>
+        </p:spPr>
+        <p:txBody>
+          <a:bodyPr wrap="square" anchor="ctr">
+            <a:spAutoFit/>
+          </a:bodyPr>
+          <a:lstStyle/>
+          <a:p>
+            <a:r>
+              <a:rPr sz="1350" b="0">
+                <a:solidFill>
+                  <a:srgbClr val="1B3A5C"/>
+                </a:solidFill>
+              </a:rPr>
+              <a:t>Démonstration — Awali en action</a:t>
+            </a:r>
+          </a:p>
+        </p:txBody>
+      </p:sp>
+      <p:sp>
+        <p:nvSpPr>
+          <p:cNvPr id="29" name="Rounded Rectangle 28"/>
+          <p:cNvSpPr/>
+          <p:nvPr/>
+        </p:nvSpPr>
+        <p:spPr>
+          <a:xfrm>
+            <a:off x="4709160" y="2491740"/>
+            <a:ext cx="329184" cy="329184"/>
+          </a:xfrm>
+          <a:prstGeom prst="roundRect">
+            <a:avLst>
+              <a:gd name="adj" fmla="val 18000"/>
+            </a:avLst>
+          </a:prstGeom>
+          <a:solidFill>
+            <a:srgbClr val="00B4D8"/>
+          </a:solidFill>
+          <a:ln>
+            <a:noFill/>
+          </a:ln>
+          <a:effectLst/>
+        </p:spPr>
+        <p:style>
+          <a:lnRef idx="1">
+            <a:schemeClr val="accent1"/>
+          </a:lnRef>
+          <a:fillRef idx="3">
+            <a:schemeClr val="accent1"/>
+          </a:fillRef>
+          <a:effectRef idx="2">
+            <a:schemeClr val="accent1"/>
+          </a:effectRef>
+          <a:fontRef idx="minor">
+            <a:schemeClr val="lt1"/>
+          </a:fontRef>
+        </p:style>
+        <p:txBody>
+          <a:bodyPr rtlCol="0" anchor="ctr" wrap="none" lIns="0" rIns="0" tIns="0" bIns="0"/>
+          <a:lstStyle/>
+          <a:p>
+            <a:pPr algn="ctr"/>
+            <a:r>
+              <a:rPr sz="1300" b="1">
+                <a:solidFill>
+                  <a:srgbClr val="FFFFFF"/>
+                </a:solidFill>
+              </a:rPr>
+              <a:t>10</a:t>
+            </a:r>
+          </a:p>
+        </p:txBody>
+      </p:sp>
+      <p:sp>
+        <p:nvSpPr>
+          <p:cNvPr id="30" name="TextBox 29"/>
+          <p:cNvSpPr txBox="1"/>
+          <p:nvPr/>
+        </p:nvSpPr>
+        <p:spPr>
+          <a:xfrm>
+            <a:off x="5166360" y="2471740"/>
+            <a:ext cx="3749039" cy="384048"/>
+          </a:xfrm>
+          <a:prstGeom prst="rect">
+            <a:avLst/>
+          </a:prstGeom>
+          <a:noFill/>
+        </p:spPr>
+        <p:txBody>
+          <a:bodyPr wrap="square" anchor="ctr">
+            <a:spAutoFit/>
+          </a:bodyPr>
+          <a:lstStyle/>
+          <a:p>
+            <a:r>
+              <a:rPr sz="1350" b="0">
+                <a:solidFill>
+                  <a:srgbClr val="1B3A5C"/>
+                </a:solidFill>
+              </a:rPr>
+              <a:t>Marketing, vente et concurrence</a:t>
+            </a:r>
+          </a:p>
+        </p:txBody>
+      </p:sp>
+      <p:sp>
+        <p:nvSpPr>
+          <p:cNvPr id="31" name="Rounded Rectangle 30"/>
+          <p:cNvSpPr/>
+          <p:nvPr/>
+        </p:nvSpPr>
+        <p:spPr>
+          <a:xfrm>
+            <a:off x="4709160" y="2962656"/>
+            <a:ext cx="329184" cy="329184"/>
+          </a:xfrm>
+          <a:prstGeom prst="roundRect">
+            <a:avLst>
+              <a:gd name="adj" fmla="val 18000"/>
+            </a:avLst>
+          </a:prstGeom>
+          <a:solidFill>
+            <a:srgbClr val="00B4D8"/>
+          </a:solidFill>
+          <a:ln>
+            <a:noFill/>
+          </a:ln>
+          <a:effectLst/>
+        </p:spPr>
+        <p:style>
+          <a:lnRef idx="1">
+            <a:schemeClr val="accent1"/>
+          </a:lnRef>
+          <a:fillRef idx="3">
+            <a:schemeClr val="accent1"/>
+          </a:fillRef>
+          <a:effectRef idx="2">
+            <a:schemeClr val="accent1"/>
+          </a:effectRef>
+          <a:fontRef idx="minor">
+            <a:schemeClr val="lt1"/>
+          </a:fontRef>
+        </p:style>
+        <p:txBody>
+          <a:bodyPr rtlCol="0" anchor="ctr" wrap="none" lIns="0" rIns="0" tIns="0" bIns="0"/>
+          <a:lstStyle/>
+          <a:p>
+            <a:pPr algn="ctr"/>
+            <a:r>
+              <a:rPr sz="1300" b="1">
+                <a:solidFill>
+                  <a:srgbClr val="FFFFFF"/>
+                </a:solidFill>
+              </a:rPr>
+              <a:t>11</a:t>
+            </a:r>
+          </a:p>
+        </p:txBody>
+      </p:sp>
+      <p:sp>
+        <p:nvSpPr>
+          <p:cNvPr id="32" name="TextBox 31"/>
+          <p:cNvSpPr txBox="1"/>
+          <p:nvPr/>
+        </p:nvSpPr>
+        <p:spPr>
+          <a:xfrm>
+            <a:off x="5166360" y="2942656"/>
+            <a:ext cx="3749039" cy="384048"/>
+          </a:xfrm>
+          <a:prstGeom prst="rect">
+            <a:avLst/>
+          </a:prstGeom>
+          <a:noFill/>
+        </p:spPr>
+        <p:txBody>
+          <a:bodyPr wrap="square" anchor="ctr">
+            <a:spAutoFit/>
+          </a:bodyPr>
+          <a:lstStyle/>
+          <a:p>
+            <a:r>
+              <a:rPr sz="1350" b="0">
+                <a:solidFill>
+                  <a:srgbClr val="1B3A5C"/>
+                </a:solidFill>
+              </a:rPr>
+              <a:t>Prévisions financières</a:t>
+            </a:r>
+          </a:p>
+        </p:txBody>
+      </p:sp>
+      <p:sp>
+        <p:nvSpPr>
+          <p:cNvPr id="33" name="Rounded Rectangle 32"/>
+          <p:cNvSpPr/>
+          <p:nvPr/>
+        </p:nvSpPr>
+        <p:spPr>
+          <a:xfrm>
+            <a:off x="4709160" y="3433572"/>
+            <a:ext cx="329184" cy="329184"/>
+          </a:xfrm>
+          <a:prstGeom prst="roundRect">
+            <a:avLst>
+              <a:gd name="adj" fmla="val 18000"/>
+            </a:avLst>
+          </a:prstGeom>
+          <a:solidFill>
+            <a:srgbClr val="00B4D8"/>
+          </a:solidFill>
+          <a:ln>
+            <a:noFill/>
+          </a:ln>
+          <a:effectLst/>
+        </p:spPr>
+        <p:style>
+          <a:lnRef idx="1">
+            <a:schemeClr val="accent1"/>
+          </a:lnRef>
+          <a:fillRef idx="3">
+            <a:schemeClr val="accent1"/>
+          </a:fillRef>
+          <a:effectRef idx="2">
+            <a:schemeClr val="accent1"/>
+          </a:effectRef>
+          <a:fontRef idx="minor">
+            <a:schemeClr val="lt1"/>
+          </a:fontRef>
+        </p:style>
+        <p:txBody>
+          <a:bodyPr rtlCol="0" anchor="ctr" wrap="none" lIns="0" rIns="0" tIns="0" bIns="0"/>
+          <a:lstStyle/>
+          <a:p>
+            <a:pPr algn="ctr"/>
+            <a:r>
+              <a:rPr sz="1300" b="1">
+                <a:solidFill>
+                  <a:srgbClr val="FFFFFF"/>
+                </a:solidFill>
+              </a:rPr>
+              <a:t>12</a:t>
+            </a:r>
+          </a:p>
+        </p:txBody>
+      </p:sp>
+      <p:sp>
+        <p:nvSpPr>
+          <p:cNvPr id="34" name="TextBox 33"/>
+          <p:cNvSpPr txBox="1"/>
+          <p:nvPr/>
+        </p:nvSpPr>
+        <p:spPr>
+          <a:xfrm>
+            <a:off x="5166360" y="3413572"/>
+            <a:ext cx="3749039" cy="384048"/>
+          </a:xfrm>
+          <a:prstGeom prst="rect">
+            <a:avLst/>
+          </a:prstGeom>
+          <a:noFill/>
+        </p:spPr>
+        <p:txBody>
+          <a:bodyPr wrap="square" anchor="ctr">
+            <a:spAutoFit/>
+          </a:bodyPr>
+          <a:lstStyle/>
+          <a:p>
+            <a:r>
+              <a:rPr sz="1350" b="0">
+                <a:solidFill>
+                  <a:srgbClr val="1B3A5C"/>
+                </a:solidFill>
+              </a:rPr>
+              <a:t>Limites actuelles &amp; perspectives</a:t>
+            </a:r>
+          </a:p>
+        </p:txBody>
+      </p:sp>
+      <p:sp>
+        <p:nvSpPr>
+          <p:cNvPr id="35" name="Rounded Rectangle 34"/>
+          <p:cNvSpPr/>
+          <p:nvPr/>
+        </p:nvSpPr>
+        <p:spPr>
+          <a:xfrm>
+            <a:off x="4709160" y="3904488"/>
+            <a:ext cx="329184" cy="329184"/>
+          </a:xfrm>
+          <a:prstGeom prst="roundRect">
+            <a:avLst>
+              <a:gd name="adj" fmla="val 18000"/>
+            </a:avLst>
+          </a:prstGeom>
+          <a:solidFill>
+            <a:srgbClr val="00B4D8"/>
+          </a:solidFill>
+          <a:ln>
+            <a:noFill/>
+          </a:ln>
+          <a:effectLst/>
+        </p:spPr>
+        <p:style>
+          <a:lnRef idx="1">
+            <a:schemeClr val="accent1"/>
+          </a:lnRef>
+          <a:fillRef idx="3">
+            <a:schemeClr val="accent1"/>
+          </a:fillRef>
+          <a:effectRef idx="2">
+            <a:schemeClr val="accent1"/>
+          </a:effectRef>
+          <a:fontRef idx="minor">
+            <a:schemeClr val="lt1"/>
+          </a:fontRef>
+        </p:style>
+        <p:txBody>
+          <a:bodyPr rtlCol="0" anchor="ctr" wrap="none" lIns="0" rIns="0" tIns="0" bIns="0"/>
+          <a:lstStyle/>
+          <a:p>
+            <a:pPr algn="ctr"/>
+            <a:r>
+              <a:rPr sz="1600" b="1">
+                <a:solidFill>
+                  <a:srgbClr val="FFFFFF"/>
+                </a:solidFill>
+              </a:rPr>
+              <a:t>•</a:t>
+            </a:r>
+          </a:p>
+        </p:txBody>
+      </p:sp>
+      <p:sp>
+        <p:nvSpPr>
+          <p:cNvPr id="36" name="TextBox 35"/>
+          <p:cNvSpPr txBox="1"/>
+          <p:nvPr/>
+        </p:nvSpPr>
+        <p:spPr>
+          <a:xfrm>
+            <a:off x="5166360" y="3884488"/>
+            <a:ext cx="3749039" cy="384048"/>
+          </a:xfrm>
+          <a:prstGeom prst="rect">
+            <a:avLst/>
+          </a:prstGeom>
+          <a:noFill/>
+        </p:spPr>
+        <p:txBody>
+          <a:bodyPr wrap="square" anchor="ctr">
+            <a:spAutoFit/>
+          </a:bodyPr>
+          <a:lstStyle/>
+          <a:p>
+            <a:r>
+              <a:rPr sz="1350" b="1">
+                <a:solidFill>
+                  <a:srgbClr val="1B3A5C"/>
+                </a:solidFill>
+              </a:rPr>
+              <a:t>Conclusion</a:t>
+            </a:r>
           </a:p>
         </p:txBody>
       </p:sp>

</xml_diff>